<commit_message>
fix: validate sermon PPTX packages and improve slide typography
</commit_message>
<xml_diff>
--- a/skills/sermon-deck/assets/template.pptx
+++ b/skills/sermon-deck/assets/template.pptx
@@ -251,7 +251,7 @@
           <a:p>
             <a:fld id="{B4C60C73-FFFC-4A4A-9329-24BB1DB7F020}" type="datetimeFigureOut">
               <a:rPr lang="en-RU" smtClean="0"/>
-              <a:t>12.04.2026</a:t>
+              <a:t>04.10.2026</a:t>
             </a:fld>
             <a:endParaRPr lang="en-RU"/>
           </a:p>
@@ -772,7 +772,7 @@
           <a:p>
             <a:fld id="{826DB63D-4BD7-1E48-853C-479D9D30EC30}" type="datetimeFigureOut">
               <a:rPr lang="en-RU" smtClean="0"/>
-              <a:t>12.04.2026</a:t>
+              <a:t>04.10.2026</a:t>
             </a:fld>
             <a:endParaRPr lang="en-RU"/>
           </a:p>
@@ -972,7 +972,7 @@
           <a:p>
             <a:fld id="{826DB63D-4BD7-1E48-853C-479D9D30EC30}" type="datetimeFigureOut">
               <a:rPr lang="en-RU" smtClean="0"/>
-              <a:t>12.04.2026</a:t>
+              <a:t>04.10.2026</a:t>
             </a:fld>
             <a:endParaRPr lang="en-RU"/>
           </a:p>
@@ -1182,7 +1182,7 @@
           <a:p>
             <a:fld id="{826DB63D-4BD7-1E48-853C-479D9D30EC30}" type="datetimeFigureOut">
               <a:rPr lang="en-RU" smtClean="0"/>
-              <a:t>12.04.2026</a:t>
+              <a:t>04.10.2026</a:t>
             </a:fld>
             <a:endParaRPr lang="en-RU"/>
           </a:p>
@@ -1382,7 +1382,7 @@
           <a:p>
             <a:fld id="{826DB63D-4BD7-1E48-853C-479D9D30EC30}" type="datetimeFigureOut">
               <a:rPr lang="en-RU" smtClean="0"/>
-              <a:t>12.04.2026</a:t>
+              <a:t>04.10.2026</a:t>
             </a:fld>
             <a:endParaRPr lang="en-RU"/>
           </a:p>
@@ -1658,7 +1658,7 @@
           <a:p>
             <a:fld id="{826DB63D-4BD7-1E48-853C-479D9D30EC30}" type="datetimeFigureOut">
               <a:rPr lang="en-RU" smtClean="0"/>
-              <a:t>12.04.2026</a:t>
+              <a:t>04.10.2026</a:t>
             </a:fld>
             <a:endParaRPr lang="en-RU"/>
           </a:p>
@@ -1926,7 +1926,7 @@
           <a:p>
             <a:fld id="{826DB63D-4BD7-1E48-853C-479D9D30EC30}" type="datetimeFigureOut">
               <a:rPr lang="en-RU" smtClean="0"/>
-              <a:t>12.04.2026</a:t>
+              <a:t>04.10.2026</a:t>
             </a:fld>
             <a:endParaRPr lang="en-RU"/>
           </a:p>
@@ -2341,7 +2341,7 @@
           <a:p>
             <a:fld id="{826DB63D-4BD7-1E48-853C-479D9D30EC30}" type="datetimeFigureOut">
               <a:rPr lang="en-RU" smtClean="0"/>
-              <a:t>12.04.2026</a:t>
+              <a:t>04.10.2026</a:t>
             </a:fld>
             <a:endParaRPr lang="en-RU"/>
           </a:p>
@@ -2483,7 +2483,7 @@
           <a:p>
             <a:fld id="{826DB63D-4BD7-1E48-853C-479D9D30EC30}" type="datetimeFigureOut">
               <a:rPr lang="en-RU" smtClean="0"/>
-              <a:t>12.04.2026</a:t>
+              <a:t>04.10.2026</a:t>
             </a:fld>
             <a:endParaRPr lang="en-RU"/>
           </a:p>
@@ -2596,7 +2596,7 @@
           <a:p>
             <a:fld id="{826DB63D-4BD7-1E48-853C-479D9D30EC30}" type="datetimeFigureOut">
               <a:rPr lang="en-RU" smtClean="0"/>
-              <a:t>12.04.2026</a:t>
+              <a:t>04.10.2026</a:t>
             </a:fld>
             <a:endParaRPr lang="en-RU"/>
           </a:p>
@@ -2909,7 +2909,7 @@
           <a:p>
             <a:fld id="{826DB63D-4BD7-1E48-853C-479D9D30EC30}" type="datetimeFigureOut">
               <a:rPr lang="en-RU" smtClean="0"/>
-              <a:t>12.04.2026</a:t>
+              <a:t>04.10.2026</a:t>
             </a:fld>
             <a:endParaRPr lang="en-RU"/>
           </a:p>
@@ -3198,7 +3198,7 @@
           <a:p>
             <a:fld id="{826DB63D-4BD7-1E48-853C-479D9D30EC30}" type="datetimeFigureOut">
               <a:rPr lang="en-RU" smtClean="0"/>
-              <a:t>12.04.2026</a:t>
+              <a:t>04.10.2026</a:t>
             </a:fld>
             <a:endParaRPr lang="en-RU"/>
           </a:p>
@@ -3441,7 +3441,7 @@
           <a:p>
             <a:fld id="{826DB63D-4BD7-1E48-853C-479D9D30EC30}" type="datetimeFigureOut">
               <a:rPr lang="en-RU" smtClean="0"/>
-              <a:t>12.04.2026</a:t>
+              <a:t>04.10.2026</a:t>
             </a:fld>
             <a:endParaRPr lang="en-RU"/>
           </a:p>

</xml_diff>

<commit_message>
fix: repair sermon PPTX packages and improve slide layout (#1)
* fix: validate sermon PPTX packages and improve slide typography

* fix: compact headings and preserve angular quote decorations
</commit_message>
<xml_diff>
--- a/skills/sermon-deck/assets/template.pptx
+++ b/skills/sermon-deck/assets/template.pptx
@@ -251,7 +251,7 @@
           <a:p>
             <a:fld id="{B4C60C73-FFFC-4A4A-9329-24BB1DB7F020}" type="datetimeFigureOut">
               <a:rPr lang="en-RU" smtClean="0"/>
-              <a:t>12.04.2026</a:t>
+              <a:t>04.10.2026</a:t>
             </a:fld>
             <a:endParaRPr lang="en-RU"/>
           </a:p>
@@ -772,7 +772,7 @@
           <a:p>
             <a:fld id="{826DB63D-4BD7-1E48-853C-479D9D30EC30}" type="datetimeFigureOut">
               <a:rPr lang="en-RU" smtClean="0"/>
-              <a:t>12.04.2026</a:t>
+              <a:t>04.10.2026</a:t>
             </a:fld>
             <a:endParaRPr lang="en-RU"/>
           </a:p>
@@ -972,7 +972,7 @@
           <a:p>
             <a:fld id="{826DB63D-4BD7-1E48-853C-479D9D30EC30}" type="datetimeFigureOut">
               <a:rPr lang="en-RU" smtClean="0"/>
-              <a:t>12.04.2026</a:t>
+              <a:t>04.10.2026</a:t>
             </a:fld>
             <a:endParaRPr lang="en-RU"/>
           </a:p>
@@ -1182,7 +1182,7 @@
           <a:p>
             <a:fld id="{826DB63D-4BD7-1E48-853C-479D9D30EC30}" type="datetimeFigureOut">
               <a:rPr lang="en-RU" smtClean="0"/>
-              <a:t>12.04.2026</a:t>
+              <a:t>04.10.2026</a:t>
             </a:fld>
             <a:endParaRPr lang="en-RU"/>
           </a:p>
@@ -1382,7 +1382,7 @@
           <a:p>
             <a:fld id="{826DB63D-4BD7-1E48-853C-479D9D30EC30}" type="datetimeFigureOut">
               <a:rPr lang="en-RU" smtClean="0"/>
-              <a:t>12.04.2026</a:t>
+              <a:t>04.10.2026</a:t>
             </a:fld>
             <a:endParaRPr lang="en-RU"/>
           </a:p>
@@ -1658,7 +1658,7 @@
           <a:p>
             <a:fld id="{826DB63D-4BD7-1E48-853C-479D9D30EC30}" type="datetimeFigureOut">
               <a:rPr lang="en-RU" smtClean="0"/>
-              <a:t>12.04.2026</a:t>
+              <a:t>04.10.2026</a:t>
             </a:fld>
             <a:endParaRPr lang="en-RU"/>
           </a:p>
@@ -1926,7 +1926,7 @@
           <a:p>
             <a:fld id="{826DB63D-4BD7-1E48-853C-479D9D30EC30}" type="datetimeFigureOut">
               <a:rPr lang="en-RU" smtClean="0"/>
-              <a:t>12.04.2026</a:t>
+              <a:t>04.10.2026</a:t>
             </a:fld>
             <a:endParaRPr lang="en-RU"/>
           </a:p>
@@ -2341,7 +2341,7 @@
           <a:p>
             <a:fld id="{826DB63D-4BD7-1E48-853C-479D9D30EC30}" type="datetimeFigureOut">
               <a:rPr lang="en-RU" smtClean="0"/>
-              <a:t>12.04.2026</a:t>
+              <a:t>04.10.2026</a:t>
             </a:fld>
             <a:endParaRPr lang="en-RU"/>
           </a:p>
@@ -2483,7 +2483,7 @@
           <a:p>
             <a:fld id="{826DB63D-4BD7-1E48-853C-479D9D30EC30}" type="datetimeFigureOut">
               <a:rPr lang="en-RU" smtClean="0"/>
-              <a:t>12.04.2026</a:t>
+              <a:t>04.10.2026</a:t>
             </a:fld>
             <a:endParaRPr lang="en-RU"/>
           </a:p>
@@ -2596,7 +2596,7 @@
           <a:p>
             <a:fld id="{826DB63D-4BD7-1E48-853C-479D9D30EC30}" type="datetimeFigureOut">
               <a:rPr lang="en-RU" smtClean="0"/>
-              <a:t>12.04.2026</a:t>
+              <a:t>04.10.2026</a:t>
             </a:fld>
             <a:endParaRPr lang="en-RU"/>
           </a:p>
@@ -2909,7 +2909,7 @@
           <a:p>
             <a:fld id="{826DB63D-4BD7-1E48-853C-479D9D30EC30}" type="datetimeFigureOut">
               <a:rPr lang="en-RU" smtClean="0"/>
-              <a:t>12.04.2026</a:t>
+              <a:t>04.10.2026</a:t>
             </a:fld>
             <a:endParaRPr lang="en-RU"/>
           </a:p>
@@ -3198,7 +3198,7 @@
           <a:p>
             <a:fld id="{826DB63D-4BD7-1E48-853C-479D9D30EC30}" type="datetimeFigureOut">
               <a:rPr lang="en-RU" smtClean="0"/>
-              <a:t>12.04.2026</a:t>
+              <a:t>04.10.2026</a:t>
             </a:fld>
             <a:endParaRPr lang="en-RU"/>
           </a:p>
@@ -3441,7 +3441,7 @@
           <a:p>
             <a:fld id="{826DB63D-4BD7-1E48-853C-479D9D30EC30}" type="datetimeFigureOut">
               <a:rPr lang="en-RU" smtClean="0"/>
-              <a:t>12.04.2026</a:t>
+              <a:t>04.10.2026</a:t>
             </a:fld>
             <a:endParaRPr lang="en-RU"/>
           </a:p>

</xml_diff>